<commit_message>
Slides: why AlphaFold3 is better (TM gap split by template coverage)
</commit_message>
<xml_diff>
--- a/results/slides.pptx
+++ b/results/slides.pptx
@@ -20,6 +20,7 @@
     <p:sldId id="268" r:id="rId20"/>
     <p:sldId id="269" r:id="rId21"/>
     <p:sldId id="270" r:id="rId22"/>
+    <p:sldId id="271" r:id="rId23"/>
   </p:sldIdLst>
   <p:sldSz cx="12191695" cy="6858000" type="screen4x3"/>
   <p:notesSz cx="6858000" cy="9144000"/>
@@ -1579,7 +1580,7 @@
           <a:lstStyle/>
           <a:p>
             <a:r>
-              <a:t>Three targets is a small sample: these are case studies, not trends.</a:t>
+              <a:t>The TM-score gap is split by template coverage: each model's TM-score is recomputed over template-covered residues only (normalised by the full EU); the rest of the gap is in uncovered residues. The two parts use separate superpositions, so the split is approximate. Homologues at 30–40% identity typically differ by 1.5–2.5 Å, which caps how close a copied template can be.</a:t>
             </a:r>
           </a:p>
         </p:txBody>
@@ -1605,6 +1606,76 @@
 </file>
 
 <file path=ppt/notesSlides/notesSlide14.xml><?xml version="1.0" encoding="utf-8"?>
+<p:notes xmlns:a="http://schemas.openxmlformats.org/drawingml/2006/main" xmlns:p="http://schemas.openxmlformats.org/presentationml/2006/main" xmlns:r="http://schemas.openxmlformats.org/officeDocument/2006/relationships">
+  <p:cSld>
+    <p:spTree>
+      <p:nvGrpSpPr>
+        <p:cNvPr id="1" name=""/>
+        <p:cNvGrpSpPr/>
+        <p:nvPr/>
+      </p:nvGrpSpPr>
+      <p:grpSpPr>
+        <a:xfrm>
+          <a:off x="0" y="0"/>
+          <a:ext cx="0" cy="0"/>
+          <a:chOff x="0" y="0"/>
+          <a:chExt cx="0" cy="0"/>
+        </a:xfrm>
+      </p:grpSpPr>
+      <p:sp>
+        <p:nvSpPr>
+          <p:cNvPr id="2" name="Slide Image Placeholder 1"/>
+          <p:cNvSpPr>
+            <a:spLocks noGrp="1"/>
+          </p:cNvSpPr>
+          <p:nvPr>
+            <p:ph type="sldImg" idx="2"/>
+          </p:nvPr>
+        </p:nvSpPr>
+        <p:spPr/>
+      </p:sp>
+      <p:sp>
+        <p:nvSpPr>
+          <p:cNvPr id="3" name="Notes Placeholder 2"/>
+          <p:cNvSpPr>
+            <a:spLocks noGrp="1"/>
+          </p:cNvSpPr>
+          <p:nvPr>
+            <p:ph type="body" idx="3" sz="quarter"/>
+          </p:nvPr>
+        </p:nvSpPr>
+        <p:spPr/>
+        <p:txBody>
+          <a:bodyPr/>
+          <a:lstStyle/>
+          <a:p>
+            <a:r>
+              <a:t>Three targets is a small sample: these are case studies, not trends.</a:t>
+            </a:r>
+          </a:p>
+        </p:txBody>
+      </p:sp>
+      <p:sp>
+        <p:nvSpPr>
+          <p:cNvPr id="4" name="Slide Number Placeholder 3"/>
+          <p:cNvSpPr>
+            <a:spLocks noGrp="1"/>
+          </p:cNvSpPr>
+          <p:nvPr>
+            <p:ph type="sldNum" idx="5" sz="quarter"/>
+          </p:nvPr>
+        </p:nvSpPr>
+        <p:spPr/>
+      </p:sp>
+    </p:spTree>
+  </p:cSld>
+  <p:clrMapOvr>
+    <a:masterClrMapping/>
+  </p:clrMapOvr>
+</p:notes>
+</file>
+
+<file path=ppt/notesSlides/notesSlide15.xml><?xml version="1.0" encoding="utf-8"?>
 <p:notes xmlns:a="http://schemas.openxmlformats.org/drawingml/2006/main" xmlns:p="http://schemas.openxmlformats.org/presentationml/2006/main" xmlns:r="http://schemas.openxmlformats.org/officeDocument/2006/relationships">
   <p:cSld>
     <p:spTree>
@@ -7899,7 +7970,7 @@
                 </a:solidFill>
                 <a:latin typeface="Calibri"/>
               </a:rPr>
-              <a:t>Key findings</a:t>
+              <a:t>Why is AlphaFold3 so much better?</a:t>
             </a:r>
           </a:p>
         </p:txBody>
@@ -8017,16 +8088,600 @@
           </a:p>
         </p:txBody>
       </p:sp>
-      <p:sp>
-        <p:nvSpPr>
-          <p:cNvPr id="7" name="Rectangle 6"/>
+      <p:graphicFrame>
+        <p:nvGraphicFramePr>
+          <p:cNvPr id="7" name="Table 6"/>
+          <p:cNvGraphicFramePr>
+            <a:graphicFrameLocks noGrp="1"/>
+          </p:cNvGraphicFramePr>
+          <p:nvPr/>
+        </p:nvGraphicFramePr>
+        <p:xfrm>
+          <a:off x="548640" y="1463040"/>
+          <a:ext cx="6035040" cy="1828800"/>
+        </p:xfrm>
+        <a:graphic>
+          <a:graphicData uri="http://schemas.openxmlformats.org/drawingml/2006/table">
+            <a:tbl>
+              <a:tblPr firstRow="1" bandRow="1">
+                <a:tableStyleId>{5C22544A-7EE6-4342-B048-85BDC9FD1C3A}</a:tableStyleId>
+              </a:tblPr>
+              <a:tblGrid>
+                <a:gridCol w="1097280"/>
+                <a:gridCol w="1097280"/>
+                <a:gridCol w="1005840"/>
+                <a:gridCol w="1417320"/>
+                <a:gridCol w="1417320"/>
+              </a:tblGrid>
+              <a:tr h="457200">
+                <a:tc>
+                  <a:txBody>
+                    <a:bodyPr wrap="square"/>
+                    <a:lstStyle/>
+                    <a:p>
+                      <a:pPr algn="l"/>
+                      <a:r>
+                        <a:rPr sz="1300" b="1">
+                          <a:solidFill>
+                            <a:srgbClr val="FFFFFF"/>
+                          </a:solidFill>
+                          <a:latin typeface="Calibri"/>
+                        </a:rPr>
+                        <a:t>Target</a:t>
+                      </a:r>
+                    </a:p>
+                  </a:txBody>
+                  <a:tcPr marL="73152" marR="73152" marT="27432" marB="27432" anchor="ctr">
+                    <a:solidFill>
+                      <a:srgbClr val="0B0B0B"/>
+                    </a:solidFill>
+                  </a:tcPr>
+                </a:tc>
+                <a:tc>
+                  <a:txBody>
+                    <a:bodyPr wrap="square"/>
+                    <a:lstStyle/>
+                    <a:p>
+                      <a:pPr algn="ctr"/>
+                      <a:r>
+                        <a:rPr sz="1300" b="1">
+                          <a:solidFill>
+                            <a:srgbClr val="FFFFFF"/>
+                          </a:solidFill>
+                          <a:latin typeface="Calibri"/>
+                        </a:rPr>
+                        <a:t>EU covered</a:t>
+                      </a:r>
+                    </a:p>
+                  </a:txBody>
+                  <a:tcPr marL="73152" marR="73152" marT="27432" marB="27432" anchor="ctr">
+                    <a:solidFill>
+                      <a:srgbClr val="0B0B0B"/>
+                    </a:solidFill>
+                  </a:tcPr>
+                </a:tc>
+                <a:tc>
+                  <a:txBody>
+                    <a:bodyPr wrap="square"/>
+                    <a:lstStyle/>
+                    <a:p>
+                      <a:pPr algn="ctr"/>
+                      <a:r>
+                        <a:rPr sz="1300" b="1">
+                          <a:solidFill>
+                            <a:srgbClr val="FFFFFF"/>
+                          </a:solidFill>
+                          <a:latin typeface="Calibri"/>
+                        </a:rPr>
+                        <a:t>TM gap</a:t>
+                      </a:r>
+                    </a:p>
+                  </a:txBody>
+                  <a:tcPr marL="73152" marR="73152" marT="27432" marB="27432" anchor="ctr">
+                    <a:solidFill>
+                      <a:srgbClr val="0B0B0B"/>
+                    </a:solidFill>
+                  </a:tcPr>
+                </a:tc>
+                <a:tc>
+                  <a:txBody>
+                    <a:bodyPr wrap="square"/>
+                    <a:lstStyle/>
+                    <a:p>
+                      <a:pPr algn="ctr"/>
+                      <a:r>
+                        <a:rPr sz="1300" b="1">
+                          <a:solidFill>
+                            <a:srgbClr val="FFFFFF"/>
+                          </a:solidFill>
+                          <a:latin typeface="Calibri"/>
+                        </a:rPr>
+                        <a:t>in covered residues</a:t>
+                      </a:r>
+                    </a:p>
+                  </a:txBody>
+                  <a:tcPr marL="73152" marR="73152" marT="27432" marB="27432" anchor="ctr">
+                    <a:solidFill>
+                      <a:srgbClr val="0B0B0B"/>
+                    </a:solidFill>
+                  </a:tcPr>
+                </a:tc>
+                <a:tc>
+                  <a:txBody>
+                    <a:bodyPr wrap="square"/>
+                    <a:lstStyle/>
+                    <a:p>
+                      <a:pPr algn="ctr"/>
+                      <a:r>
+                        <a:rPr sz="1300" b="1">
+                          <a:solidFill>
+                            <a:srgbClr val="FFFFFF"/>
+                          </a:solidFill>
+                          <a:latin typeface="Calibri"/>
+                        </a:rPr>
+                        <a:t>in uncovered residues</a:t>
+                      </a:r>
+                    </a:p>
+                  </a:txBody>
+                  <a:tcPr marL="73152" marR="73152" marT="27432" marB="27432" anchor="ctr">
+                    <a:solidFill>
+                      <a:srgbClr val="0B0B0B"/>
+                    </a:solidFill>
+                  </a:tcPr>
+                </a:tc>
+              </a:tr>
+              <a:tr h="457200">
+                <a:tc>
+                  <a:txBody>
+                    <a:bodyPr wrap="square"/>
+                    <a:lstStyle/>
+                    <a:p>
+                      <a:pPr algn="l"/>
+                      <a:r>
+                        <a:rPr sz="1300" b="0">
+                          <a:solidFill>
+                            <a:srgbClr val="0B0B0B"/>
+                          </a:solidFill>
+                          <a:latin typeface="Calibri"/>
+                        </a:rPr>
+                        <a:t>T1124</a:t>
+                      </a:r>
+                    </a:p>
+                  </a:txBody>
+                  <a:tcPr marL="73152" marR="73152" marT="27432" marB="27432" anchor="ctr">
+                    <a:solidFill>
+                      <a:srgbClr val="FFFFFF"/>
+                    </a:solidFill>
+                  </a:tcPr>
+                </a:tc>
+                <a:tc>
+                  <a:txBody>
+                    <a:bodyPr wrap="square"/>
+                    <a:lstStyle/>
+                    <a:p>
+                      <a:pPr algn="ctr"/>
+                      <a:r>
+                        <a:rPr sz="1300" b="0">
+                          <a:solidFill>
+                            <a:srgbClr val="0B0B0B"/>
+                          </a:solidFill>
+                          <a:latin typeface="Calibri"/>
+                        </a:rPr>
+                        <a:t>83%</a:t>
+                      </a:r>
+                    </a:p>
+                  </a:txBody>
+                  <a:tcPr marL="73152" marR="73152" marT="27432" marB="27432" anchor="ctr">
+                    <a:solidFill>
+                      <a:srgbClr val="FFFFFF"/>
+                    </a:solidFill>
+                  </a:tcPr>
+                </a:tc>
+                <a:tc>
+                  <a:txBody>
+                    <a:bodyPr wrap="square"/>
+                    <a:lstStyle/>
+                    <a:p>
+                      <a:pPr algn="ctr"/>
+                      <a:r>
+                        <a:rPr sz="1300" b="0">
+                          <a:solidFill>
+                            <a:srgbClr val="0B0B0B"/>
+                          </a:solidFill>
+                          <a:latin typeface="Calibri"/>
+                        </a:rPr>
+                        <a:t>+0.40</a:t>
+                      </a:r>
+                    </a:p>
+                  </a:txBody>
+                  <a:tcPr marL="73152" marR="73152" marT="27432" marB="27432" anchor="ctr">
+                    <a:solidFill>
+                      <a:srgbClr val="FFFFFF"/>
+                    </a:solidFill>
+                  </a:tcPr>
+                </a:tc>
+                <a:tc>
+                  <a:txBody>
+                    <a:bodyPr wrap="square"/>
+                    <a:lstStyle/>
+                    <a:p>
+                      <a:pPr algn="ctr"/>
+                      <a:r>
+                        <a:rPr sz="1300" b="0">
+                          <a:solidFill>
+                            <a:srgbClr val="EB6834"/>
+                          </a:solidFill>
+                          <a:latin typeface="Calibri"/>
+                        </a:rPr>
+                        <a:t>+0.29</a:t>
+                      </a:r>
+                    </a:p>
+                  </a:txBody>
+                  <a:tcPr marL="73152" marR="73152" marT="27432" marB="27432" anchor="ctr">
+                    <a:solidFill>
+                      <a:srgbClr val="FFFFFF"/>
+                    </a:solidFill>
+                  </a:tcPr>
+                </a:tc>
+                <a:tc>
+                  <a:txBody>
+                    <a:bodyPr wrap="square"/>
+                    <a:lstStyle/>
+                    <a:p>
+                      <a:pPr algn="ctr"/>
+                      <a:r>
+                        <a:rPr sz="1300" b="0">
+                          <a:solidFill>
+                            <a:srgbClr val="0B0B0B"/>
+                          </a:solidFill>
+                          <a:latin typeface="Calibri"/>
+                        </a:rPr>
+                        <a:t>+0.11</a:t>
+                      </a:r>
+                    </a:p>
+                  </a:txBody>
+                  <a:tcPr marL="73152" marR="73152" marT="27432" marB="27432" anchor="ctr">
+                    <a:solidFill>
+                      <a:srgbClr val="FFFFFF"/>
+                    </a:solidFill>
+                  </a:tcPr>
+                </a:tc>
+              </a:tr>
+              <a:tr h="457200">
+                <a:tc>
+                  <a:txBody>
+                    <a:bodyPr wrap="square"/>
+                    <a:lstStyle/>
+                    <a:p>
+                      <a:pPr algn="l"/>
+                      <a:r>
+                        <a:rPr sz="1300" b="0">
+                          <a:solidFill>
+                            <a:srgbClr val="0B0B0B"/>
+                          </a:solidFill>
+                          <a:latin typeface="Calibri"/>
+                        </a:rPr>
+                        <a:t>T1127</a:t>
+                      </a:r>
+                    </a:p>
+                  </a:txBody>
+                  <a:tcPr marL="73152" marR="73152" marT="27432" marB="27432" anchor="ctr">
+                    <a:solidFill>
+                      <a:srgbClr val="F5F4F1"/>
+                    </a:solidFill>
+                  </a:tcPr>
+                </a:tc>
+                <a:tc>
+                  <a:txBody>
+                    <a:bodyPr wrap="square"/>
+                    <a:lstStyle/>
+                    <a:p>
+                      <a:pPr algn="ctr"/>
+                      <a:r>
+                        <a:rPr sz="1300" b="0">
+                          <a:solidFill>
+                            <a:srgbClr val="0B0B0B"/>
+                          </a:solidFill>
+                          <a:latin typeface="Calibri"/>
+                        </a:rPr>
+                        <a:t>79%</a:t>
+                      </a:r>
+                    </a:p>
+                  </a:txBody>
+                  <a:tcPr marL="73152" marR="73152" marT="27432" marB="27432" anchor="ctr">
+                    <a:solidFill>
+                      <a:srgbClr val="F5F4F1"/>
+                    </a:solidFill>
+                  </a:tcPr>
+                </a:tc>
+                <a:tc>
+                  <a:txBody>
+                    <a:bodyPr wrap="square"/>
+                    <a:lstStyle/>
+                    <a:p>
+                      <a:pPr algn="ctr"/>
+                      <a:r>
+                        <a:rPr sz="1300" b="0">
+                          <a:solidFill>
+                            <a:srgbClr val="0B0B0B"/>
+                          </a:solidFill>
+                          <a:latin typeface="Calibri"/>
+                        </a:rPr>
+                        <a:t>+0.25</a:t>
+                      </a:r>
+                    </a:p>
+                  </a:txBody>
+                  <a:tcPr marL="73152" marR="73152" marT="27432" marB="27432" anchor="ctr">
+                    <a:solidFill>
+                      <a:srgbClr val="F5F4F1"/>
+                    </a:solidFill>
+                  </a:tcPr>
+                </a:tc>
+                <a:tc>
+                  <a:txBody>
+                    <a:bodyPr wrap="square"/>
+                    <a:lstStyle/>
+                    <a:p>
+                      <a:pPr algn="ctr"/>
+                      <a:r>
+                        <a:rPr sz="1300" b="0">
+                          <a:solidFill>
+                            <a:srgbClr val="0B0B0B"/>
+                          </a:solidFill>
+                          <a:latin typeface="Calibri"/>
+                        </a:rPr>
+                        <a:t>+0.08</a:t>
+                      </a:r>
+                    </a:p>
+                  </a:txBody>
+                  <a:tcPr marL="73152" marR="73152" marT="27432" marB="27432" anchor="ctr">
+                    <a:solidFill>
+                      <a:srgbClr val="F5F4F1"/>
+                    </a:solidFill>
+                  </a:tcPr>
+                </a:tc>
+                <a:tc>
+                  <a:txBody>
+                    <a:bodyPr wrap="square"/>
+                    <a:lstStyle/>
+                    <a:p>
+                      <a:pPr algn="ctr"/>
+                      <a:r>
+                        <a:rPr sz="1300" b="0">
+                          <a:solidFill>
+                            <a:srgbClr val="EB6834"/>
+                          </a:solidFill>
+                          <a:latin typeface="Calibri"/>
+                        </a:rPr>
+                        <a:t>+0.17</a:t>
+                      </a:r>
+                    </a:p>
+                  </a:txBody>
+                  <a:tcPr marL="73152" marR="73152" marT="27432" marB="27432" anchor="ctr">
+                    <a:solidFill>
+                      <a:srgbClr val="F5F4F1"/>
+                    </a:solidFill>
+                  </a:tcPr>
+                </a:tc>
+              </a:tr>
+              <a:tr h="457200">
+                <a:tc>
+                  <a:txBody>
+                    <a:bodyPr wrap="square"/>
+                    <a:lstStyle/>
+                    <a:p>
+                      <a:pPr algn="l"/>
+                      <a:r>
+                        <a:rPr sz="1300" b="0">
+                          <a:solidFill>
+                            <a:srgbClr val="0B0B0B"/>
+                          </a:solidFill>
+                          <a:latin typeface="Calibri"/>
+                        </a:rPr>
+                        <a:t>T1151s2</a:t>
+                      </a:r>
+                    </a:p>
+                  </a:txBody>
+                  <a:tcPr marL="73152" marR="73152" marT="27432" marB="27432" anchor="ctr">
+                    <a:solidFill>
+                      <a:srgbClr val="FFFFFF"/>
+                    </a:solidFill>
+                  </a:tcPr>
+                </a:tc>
+                <a:tc>
+                  <a:txBody>
+                    <a:bodyPr wrap="square"/>
+                    <a:lstStyle/>
+                    <a:p>
+                      <a:pPr algn="ctr"/>
+                      <a:r>
+                        <a:rPr sz="1300" b="0">
+                          <a:solidFill>
+                            <a:srgbClr val="0B0B0B"/>
+                          </a:solidFill>
+                          <a:latin typeface="Calibri"/>
+                        </a:rPr>
+                        <a:t>65%</a:t>
+                      </a:r>
+                    </a:p>
+                  </a:txBody>
+                  <a:tcPr marL="73152" marR="73152" marT="27432" marB="27432" anchor="ctr">
+                    <a:solidFill>
+                      <a:srgbClr val="FFFFFF"/>
+                    </a:solidFill>
+                  </a:tcPr>
+                </a:tc>
+                <a:tc>
+                  <a:txBody>
+                    <a:bodyPr wrap="square"/>
+                    <a:lstStyle/>
+                    <a:p>
+                      <a:pPr algn="ctr"/>
+                      <a:r>
+                        <a:rPr sz="1300" b="0">
+                          <a:solidFill>
+                            <a:srgbClr val="0B0B0B"/>
+                          </a:solidFill>
+                          <a:latin typeface="Calibri"/>
+                        </a:rPr>
+                        <a:t>+0.39</a:t>
+                      </a:r>
+                    </a:p>
+                  </a:txBody>
+                  <a:tcPr marL="73152" marR="73152" marT="27432" marB="27432" anchor="ctr">
+                    <a:solidFill>
+                      <a:srgbClr val="FFFFFF"/>
+                    </a:solidFill>
+                  </a:tcPr>
+                </a:tc>
+                <a:tc>
+                  <a:txBody>
+                    <a:bodyPr wrap="square"/>
+                    <a:lstStyle/>
+                    <a:p>
+                      <a:pPr algn="ctr"/>
+                      <a:r>
+                        <a:rPr sz="1300" b="0">
+                          <a:solidFill>
+                            <a:srgbClr val="0B0B0B"/>
+                          </a:solidFill>
+                          <a:latin typeface="Calibri"/>
+                        </a:rPr>
+                        <a:t>+0.11</a:t>
+                      </a:r>
+                    </a:p>
+                  </a:txBody>
+                  <a:tcPr marL="73152" marR="73152" marT="27432" marB="27432" anchor="ctr">
+                    <a:solidFill>
+                      <a:srgbClr val="FFFFFF"/>
+                    </a:solidFill>
+                  </a:tcPr>
+                </a:tc>
+                <a:tc>
+                  <a:txBody>
+                    <a:bodyPr wrap="square"/>
+                    <a:lstStyle/>
+                    <a:p>
+                      <a:pPr algn="ctr"/>
+                      <a:r>
+                        <a:rPr sz="1300" b="0">
+                          <a:solidFill>
+                            <a:srgbClr val="EB6834"/>
+                          </a:solidFill>
+                          <a:latin typeface="Calibri"/>
+                        </a:rPr>
+                        <a:t>+0.28</a:t>
+                      </a:r>
+                    </a:p>
+                  </a:txBody>
+                  <a:tcPr marL="73152" marR="73152" marT="27432" marB="27432" anchor="ctr">
+                    <a:solidFill>
+                      <a:srgbClr val="FFFFFF"/>
+                    </a:solidFill>
+                  </a:tcPr>
+                </a:tc>
+              </a:tr>
+            </a:tbl>
+          </a:graphicData>
+        </a:graphic>
+      </p:graphicFrame>
+      <p:sp>
+        <p:nvSpPr>
+          <p:cNvPr id="8" name="TextBox 7"/>
+          <p:cNvSpPr txBox="1"/>
+          <p:nvPr/>
+        </p:nvSpPr>
+        <p:spPr>
+          <a:xfrm>
+            <a:off x="548640" y="3429000"/>
+            <a:ext cx="6035040" cy="2926080"/>
+          </a:xfrm>
+          <a:prstGeom prst="rect">
+            <a:avLst/>
+          </a:prstGeom>
+          <a:noFill/>
+        </p:spPr>
+        <p:txBody>
+          <a:bodyPr wrap="square" anchor="t" lIns="45720" rIns="45720" tIns="27432" bIns="27432">
+            <a:spAutoFit/>
+          </a:bodyPr>
+          <a:lstStyle/>
+          <a:p>
+            <a:pPr algn="l">
+              <a:spcAft>
+                <a:spcPts val="600"/>
+              </a:spcAft>
+            </a:pPr>
+            <a:r>
+              <a:rPr sz="1400" b="1">
+                <a:solidFill>
+                  <a:srgbClr val="0B0B0B"/>
+                </a:solidFill>
+                <a:latin typeface="Calibri"/>
+              </a:rPr>
+              <a:t>Where MODELLER loses (larger share in orange):</a:t>
+            </a:r>
+          </a:p>
+          <a:p>
+            <a:pPr algn="l">
+              <a:spcAft>
+                <a:spcPts val="600"/>
+              </a:spcAft>
+            </a:pPr>
+            <a:r>
+              <a:rPr sz="1300" b="0">
+                <a:solidFill>
+                  <a:srgbClr val="0B0B0B"/>
+                </a:solidFill>
+                <a:latin typeface="Calibri"/>
+              </a:rPr>
+              <a:t>No template, no structure: the T1127 insertion and the T1151s2 tail exist in no template, so MODELLER guesses them (22–35 Å off).</a:t>
+            </a:r>
+          </a:p>
+          <a:p>
+            <a:pPr algn="l">
+              <a:spcAft>
+                <a:spcPts val="600"/>
+              </a:spcAft>
+            </a:pPr>
+            <a:r>
+              <a:rPr sz="1300" b="0">
+                <a:solidFill>
+                  <a:srgbClr val="0B0B0B"/>
+                </a:solidFill>
+                <a:latin typeface="Calibri"/>
+              </a:rPr>
+              <a:t>Covered but misplaced: T1124's N-terminal domain is template-covered (27% identity) yet lands 38 Å from the native; the domain arrangement is wrong.</a:t>
+            </a:r>
+          </a:p>
+          <a:p>
+            <a:pPr algn="l">
+              <a:spcAft>
+                <a:spcPts val="600"/>
+              </a:spcAft>
+            </a:pPr>
+            <a:r>
+              <a:rPr sz="1300" b="0">
+                <a:solidFill>
+                  <a:srgbClr val="0B0B0B"/>
+                </a:solidFill>
+                <a:latin typeface="Calibri"/>
+              </a:rPr>
+              <a:t>Copying a relative caps accuracy: covered core 3.2 Å (T1127) and 2.2 Å (T1151s2) Cα RMSD vs 0.8 / 0.7 Å for AlphaFold3 on the same residues.</a:t>
+            </a:r>
+          </a:p>
+        </p:txBody>
+      </p:sp>
+      <p:sp>
+        <p:nvSpPr>
+          <p:cNvPr id="9" name="Rectangle 8"/>
           <p:cNvSpPr/>
           <p:nvPr/>
         </p:nvSpPr>
         <p:spPr>
           <a:xfrm>
-            <a:off x="548640" y="1463040"/>
-            <a:ext cx="5440680" cy="2103120"/>
+            <a:off x="6949440" y="1463040"/>
+            <a:ext cx="4663440" cy="4663440"/>
           </a:xfrm>
           <a:prstGeom prst="rect">
             <a:avLst/>
@@ -8063,20 +8718,20 @@
       </p:sp>
       <p:sp>
         <p:nvSpPr>
-          <p:cNvPr id="8" name="Rectangle 7"/>
+          <p:cNvPr id="10" name="Rectangle 9"/>
           <p:cNvSpPr/>
           <p:nvPr/>
         </p:nvSpPr>
         <p:spPr>
           <a:xfrm>
-            <a:off x="548640" y="1463040"/>
-            <a:ext cx="82296" cy="2103120"/>
+            <a:off x="6949440" y="1463040"/>
+            <a:ext cx="82296" cy="4663440"/>
           </a:xfrm>
           <a:prstGeom prst="rect">
             <a:avLst/>
           </a:prstGeom>
           <a:solidFill>
-            <a:srgbClr val="2A78D6"/>
+            <a:srgbClr val="EB6834"/>
           </a:solidFill>
           <a:ln>
             <a:noFill/>
@@ -8107,14 +8762,14 @@
       </p:sp>
       <p:sp>
         <p:nvSpPr>
-          <p:cNvPr id="9" name="TextBox 8"/>
+          <p:cNvPr id="11" name="TextBox 10"/>
           <p:cNvSpPr txBox="1"/>
           <p:nvPr/>
         </p:nvSpPr>
         <p:spPr>
           <a:xfrm>
-            <a:off x="822959" y="1645920"/>
-            <a:ext cx="5029200" cy="457200"/>
+            <a:off x="7223760" y="1645920"/>
+            <a:ext cx="4206240" cy="4389120"/>
           </a:xfrm>
           <a:prstGeom prst="rect">
             <a:avLst/>
@@ -8129,554 +8784,81 @@
           <a:p>
             <a:pPr algn="l">
               <a:spcAft>
-                <a:spcPts val="600"/>
+                <a:spcPts val="1000"/>
               </a:spcAft>
             </a:pPr>
             <a:r>
-              <a:rPr sz="1900" b="1">
+              <a:rPr sz="1700" b="1">
                 <a:solidFill>
                   <a:srgbClr val="0B0B0B"/>
                 </a:solidFill>
                 <a:latin typeface="Calibri"/>
               </a:rPr>
-              <a:t>Template coverage sets the ceiling</a:t>
-            </a:r>
-          </a:p>
-        </p:txBody>
-      </p:sp>
-      <p:sp>
-        <p:nvSpPr>
-          <p:cNvPr id="10" name="TextBox 9"/>
-          <p:cNvSpPr txBox="1"/>
-          <p:nvPr/>
-        </p:nvSpPr>
-        <p:spPr>
-          <a:xfrm>
-            <a:off x="822959" y="2194560"/>
-            <a:ext cx="5029200" cy="1280160"/>
-          </a:xfrm>
-          <a:prstGeom prst="rect">
-            <a:avLst/>
-          </a:prstGeom>
-          <a:noFill/>
-        </p:spPr>
-        <p:txBody>
-          <a:bodyPr wrap="square" anchor="t" lIns="45720" rIns="45720" tIns="27432" bIns="27432">
-            <a:spAutoFit/>
-          </a:bodyPr>
-          <a:lstStyle/>
+              <a:t>Why AlphaFold3 avoids this</a:t>
+            </a:r>
+          </a:p>
           <a:p>
             <a:pPr algn="l">
               <a:spcAft>
-                <a:spcPts val="600"/>
+                <a:spcPts val="1000"/>
               </a:spcAft>
             </a:pPr>
             <a:r>
               <a:rPr sz="1400" b="0">
                 <a:solidFill>
-                  <a:srgbClr val="52514E"/>
-                </a:solidFill>
-                <a:latin typeface="Calibri"/>
-              </a:rPr>
-              <a:t>Covered residues: 1.9 Å (T1127), 1.7 Å (T1151s2) mean Cα error. Uncovered: 22–35 Å. Residues without a template are essentially guessed.</a:t>
-            </a:r>
-          </a:p>
-        </p:txBody>
-      </p:sp>
-      <p:sp>
-        <p:nvSpPr>
-          <p:cNvPr id="11" name="Rectangle 10"/>
-          <p:cNvSpPr/>
-          <p:nvPr/>
-        </p:nvSpPr>
-        <p:spPr>
-          <a:xfrm>
-            <a:off x="6172200" y="1463040"/>
-            <a:ext cx="5440680" cy="2103120"/>
-          </a:xfrm>
-          <a:prstGeom prst="rect">
-            <a:avLst/>
-          </a:prstGeom>
-          <a:solidFill>
-            <a:srgbClr val="F5F4F1"/>
-          </a:solidFill>
-          <a:ln>
-            <a:noFill/>
-          </a:ln>
-          <a:effectLst/>
-        </p:spPr>
-        <p:style>
-          <a:lnRef idx="1">
-            <a:schemeClr val="accent1"/>
-          </a:lnRef>
-          <a:fillRef idx="3">
-            <a:schemeClr val="accent1"/>
-          </a:fillRef>
-          <a:effectRef idx="2">
-            <a:schemeClr val="accent1"/>
-          </a:effectRef>
-          <a:fontRef idx="minor">
-            <a:schemeClr val="lt1"/>
-          </a:fontRef>
-        </p:style>
-        <p:txBody>
-          <a:bodyPr rtlCol="0" anchor="ctr"/>
-          <a:lstStyle/>
-          <a:p>
-            <a:pPr algn="ctr"/>
-          </a:p>
-        </p:txBody>
-      </p:sp>
-      <p:sp>
-        <p:nvSpPr>
-          <p:cNvPr id="12" name="Rectangle 11"/>
-          <p:cNvSpPr/>
-          <p:nvPr/>
-        </p:nvSpPr>
-        <p:spPr>
-          <a:xfrm>
-            <a:off x="6172200" y="1463040"/>
-            <a:ext cx="82296" cy="2103120"/>
-          </a:xfrm>
-          <a:prstGeom prst="rect">
-            <a:avLst/>
-          </a:prstGeom>
-          <a:solidFill>
-            <a:srgbClr val="2A78D6"/>
-          </a:solidFill>
-          <a:ln>
-            <a:noFill/>
-          </a:ln>
-          <a:effectLst/>
-        </p:spPr>
-        <p:style>
-          <a:lnRef idx="1">
-            <a:schemeClr val="accent1"/>
-          </a:lnRef>
-          <a:fillRef idx="3">
-            <a:schemeClr val="accent1"/>
-          </a:fillRef>
-          <a:effectRef idx="2">
-            <a:schemeClr val="accent1"/>
-          </a:effectRef>
-          <a:fontRef idx="minor">
-            <a:schemeClr val="lt1"/>
-          </a:fontRef>
-        </p:style>
-        <p:txBody>
-          <a:bodyPr rtlCol="0" anchor="ctr"/>
-          <a:lstStyle/>
-          <a:p>
-            <a:pPr algn="ctr"/>
-          </a:p>
-        </p:txBody>
-      </p:sp>
-      <p:sp>
-        <p:nvSpPr>
-          <p:cNvPr id="13" name="TextBox 12"/>
-          <p:cNvSpPr txBox="1"/>
-          <p:nvPr/>
-        </p:nvSpPr>
-        <p:spPr>
-          <a:xfrm>
-            <a:off x="6446520" y="1645920"/>
-            <a:ext cx="5029200" cy="457200"/>
-          </a:xfrm>
-          <a:prstGeom prst="rect">
-            <a:avLst/>
-          </a:prstGeom>
-          <a:noFill/>
-        </p:spPr>
-        <p:txBody>
-          <a:bodyPr wrap="square" anchor="t" lIns="45720" rIns="45720" tIns="27432" bIns="27432">
-            <a:spAutoFit/>
-          </a:bodyPr>
-          <a:lstStyle/>
+                  <a:srgbClr val="0B0B0B"/>
+                </a:solidFill>
+                <a:latin typeface="Calibri"/>
+              </a:rPr>
+              <a:t>Learned from the whole PDB: it predicts this sequence's own structure instead of copying one relative's coordinates.</a:t>
+            </a:r>
+          </a:p>
           <a:p>
             <a:pPr algn="l">
               <a:spcAft>
-                <a:spcPts val="600"/>
+                <a:spcPts val="1000"/>
               </a:spcAft>
             </a:pPr>
             <a:r>
-              <a:rPr sz="1900" b="1">
+              <a:rPr sz="1400" b="0">
                 <a:solidFill>
                   <a:srgbClr val="0B0B0B"/>
                 </a:solidFill>
                 <a:latin typeface="Calibri"/>
               </a:rPr>
-              <a:t>Coverage is not enough</a:t>
-            </a:r>
-          </a:p>
-        </p:txBody>
-      </p:sp>
-      <p:sp>
-        <p:nvSpPr>
-          <p:cNvPr id="14" name="TextBox 13"/>
-          <p:cNvSpPr txBox="1"/>
-          <p:nvPr/>
-        </p:nvSpPr>
-        <p:spPr>
-          <a:xfrm>
-            <a:off x="6446520" y="2194560"/>
-            <a:ext cx="5029200" cy="1280160"/>
-          </a:xfrm>
-          <a:prstGeom prst="rect">
-            <a:avLst/>
-          </a:prstGeom>
-          <a:noFill/>
-        </p:spPr>
-        <p:txBody>
-          <a:bodyPr wrap="square" anchor="t" lIns="45720" rIns="45720" tIns="27432" bIns="27432">
-            <a:spAutoFit/>
-          </a:bodyPr>
-          <a:lstStyle/>
+              <a:t>Co-evolution from deep sequence alignments: positions that mutate together are in contact, which constrains regions no template covers.</a:t>
+            </a:r>
+          </a:p>
           <a:p>
             <a:pPr algn="l">
               <a:spcAft>
-                <a:spcPts val="600"/>
+                <a:spcPts val="1000"/>
               </a:spcAft>
             </a:pPr>
             <a:r>
               <a:rPr sz="1400" b="0">
                 <a:solidFill>
-                  <a:srgbClr val="52514E"/>
-                </a:solidFill>
-                <a:latin typeface="Calibri"/>
-              </a:rPr>
-              <a:t>T1124: 81% aligned, but a whole domain is misplaced. At ~27% identity a single template can carry the wrong domain arrangement.</a:t>
-            </a:r>
-          </a:p>
-        </p:txBody>
-      </p:sp>
-      <p:sp>
-        <p:nvSpPr>
-          <p:cNvPr id="15" name="Rectangle 14"/>
-          <p:cNvSpPr/>
-          <p:nvPr/>
-        </p:nvSpPr>
-        <p:spPr>
-          <a:xfrm>
-            <a:off x="548640" y="3794760"/>
-            <a:ext cx="5440680" cy="2103120"/>
-          </a:xfrm>
-          <a:prstGeom prst="rect">
-            <a:avLst/>
-          </a:prstGeom>
-          <a:solidFill>
-            <a:srgbClr val="F5F4F1"/>
-          </a:solidFill>
-          <a:ln>
-            <a:noFill/>
-          </a:ln>
-          <a:effectLst/>
-        </p:spPr>
-        <p:style>
-          <a:lnRef idx="1">
-            <a:schemeClr val="accent1"/>
-          </a:lnRef>
-          <a:fillRef idx="3">
-            <a:schemeClr val="accent1"/>
-          </a:fillRef>
-          <a:effectRef idx="2">
-            <a:schemeClr val="accent1"/>
-          </a:effectRef>
-          <a:fontRef idx="minor">
-            <a:schemeClr val="lt1"/>
-          </a:fontRef>
-        </p:style>
-        <p:txBody>
-          <a:bodyPr rtlCol="0" anchor="ctr"/>
-          <a:lstStyle/>
-          <a:p>
-            <a:pPr algn="ctr"/>
-          </a:p>
-        </p:txBody>
-      </p:sp>
-      <p:sp>
-        <p:nvSpPr>
-          <p:cNvPr id="16" name="Rectangle 15"/>
-          <p:cNvSpPr/>
-          <p:nvPr/>
-        </p:nvSpPr>
-        <p:spPr>
-          <a:xfrm>
-            <a:off x="548640" y="3794760"/>
-            <a:ext cx="82296" cy="2103120"/>
-          </a:xfrm>
-          <a:prstGeom prst="rect">
-            <a:avLst/>
-          </a:prstGeom>
-          <a:solidFill>
-            <a:srgbClr val="EB6834"/>
-          </a:solidFill>
-          <a:ln>
-            <a:noFill/>
-          </a:ln>
-          <a:effectLst/>
-        </p:spPr>
-        <p:style>
-          <a:lnRef idx="1">
-            <a:schemeClr val="accent1"/>
-          </a:lnRef>
-          <a:fillRef idx="3">
-            <a:schemeClr val="accent1"/>
-          </a:fillRef>
-          <a:effectRef idx="2">
-            <a:schemeClr val="accent1"/>
-          </a:effectRef>
-          <a:fontRef idx="minor">
-            <a:schemeClr val="lt1"/>
-          </a:fontRef>
-        </p:style>
-        <p:txBody>
-          <a:bodyPr rtlCol="0" anchor="ctr"/>
-          <a:lstStyle/>
-          <a:p>
-            <a:pPr algn="ctr"/>
-          </a:p>
-        </p:txBody>
-      </p:sp>
-      <p:sp>
-        <p:nvSpPr>
-          <p:cNvPr id="17" name="TextBox 16"/>
-          <p:cNvSpPr txBox="1"/>
-          <p:nvPr/>
-        </p:nvSpPr>
-        <p:spPr>
-          <a:xfrm>
-            <a:off x="822959" y="3977640"/>
-            <a:ext cx="5029200" cy="457200"/>
-          </a:xfrm>
-          <a:prstGeom prst="rect">
-            <a:avLst/>
-          </a:prstGeom>
-          <a:noFill/>
-        </p:spPr>
-        <p:txBody>
-          <a:bodyPr wrap="square" anchor="t" lIns="45720" rIns="45720" tIns="27432" bIns="27432">
-            <a:spAutoFit/>
-          </a:bodyPr>
-          <a:lstStyle/>
+                  <a:srgbClr val="0B0B0B"/>
+                </a:solidFill>
+                <a:latin typeface="Calibri"/>
+              </a:rPr>
+              <a:t>Templates are hints, not scaffolds: several are combined and adjusted to the target, so domain arrangement is not inherited from one homologue.</a:t>
+            </a:r>
+          </a:p>
           <a:p>
             <a:pPr algn="l">
               <a:spcAft>
-                <a:spcPts val="600"/>
+                <a:spcPts val="1000"/>
               </a:spcAft>
             </a:pPr>
             <a:r>
-              <a:rPr sz="1900" b="1">
-                <a:solidFill>
-                  <a:srgbClr val="0B0B0B"/>
-                </a:solidFill>
-                <a:latin typeface="Calibri"/>
-              </a:rPr>
-              <a:t>Profile search finds remote templates</a:t>
-            </a:r>
-          </a:p>
-        </p:txBody>
-      </p:sp>
-      <p:sp>
-        <p:nvSpPr>
-          <p:cNvPr id="18" name="TextBox 17"/>
-          <p:cNvSpPr txBox="1"/>
-          <p:nvPr/>
-        </p:nvSpPr>
-        <p:spPr>
-          <a:xfrm>
-            <a:off x="822959" y="4526280"/>
-            <a:ext cx="5029200" cy="1280160"/>
-          </a:xfrm>
-          <a:prstGeom prst="rect">
-            <a:avLst/>
-          </a:prstGeom>
-          <a:noFill/>
-        </p:spPr>
-        <p:txBody>
-          <a:bodyPr wrap="square" anchor="t" lIns="45720" rIns="45720" tIns="27432" bIns="27432">
-            <a:spAutoFit/>
-          </a:bodyPr>
-          <a:lstStyle/>
-          <a:p>
-            <a:pPr algn="l">
-              <a:spcAft>
-                <a:spcPts val="600"/>
-              </a:spcAft>
-            </a:pPr>
-            <a:r>
               <a:rPr sz="1400" b="0">
                 <a:solidFill>
                   <a:srgbClr val="52514E"/>
                 </a:solidFill>
                 <a:latin typeface="Calibri"/>
               </a:rPr>
-              <a:t>T1151s2 (FM/TBM): WhiB-family templates at 38% identity over 55 residues (E ≈ 1e-22) give an accurate core, TM 0.52.</a:t>
-            </a:r>
-          </a:p>
-        </p:txBody>
-      </p:sp>
-      <p:sp>
-        <p:nvSpPr>
-          <p:cNvPr id="19" name="Rectangle 18"/>
-          <p:cNvSpPr/>
-          <p:nvPr/>
-        </p:nvSpPr>
-        <p:spPr>
-          <a:xfrm>
-            <a:off x="6172200" y="3794760"/>
-            <a:ext cx="5440680" cy="2103120"/>
-          </a:xfrm>
-          <a:prstGeom prst="rect">
-            <a:avLst/>
-          </a:prstGeom>
-          <a:solidFill>
-            <a:srgbClr val="F5F4F1"/>
-          </a:solidFill>
-          <a:ln>
-            <a:noFill/>
-          </a:ln>
-          <a:effectLst/>
-        </p:spPr>
-        <p:style>
-          <a:lnRef idx="1">
-            <a:schemeClr val="accent1"/>
-          </a:lnRef>
-          <a:fillRef idx="3">
-            <a:schemeClr val="accent1"/>
-          </a:fillRef>
-          <a:effectRef idx="2">
-            <a:schemeClr val="accent1"/>
-          </a:effectRef>
-          <a:fontRef idx="minor">
-            <a:schemeClr val="lt1"/>
-          </a:fontRef>
-        </p:style>
-        <p:txBody>
-          <a:bodyPr rtlCol="0" anchor="ctr"/>
-          <a:lstStyle/>
-          <a:p>
-            <a:pPr algn="ctr"/>
-          </a:p>
-        </p:txBody>
-      </p:sp>
-      <p:sp>
-        <p:nvSpPr>
-          <p:cNvPr id="20" name="Rectangle 19"/>
-          <p:cNvSpPr/>
-          <p:nvPr/>
-        </p:nvSpPr>
-        <p:spPr>
-          <a:xfrm>
-            <a:off x="6172200" y="3794760"/>
-            <a:ext cx="82296" cy="2103120"/>
-          </a:xfrm>
-          <a:prstGeom prst="rect">
-            <a:avLst/>
-          </a:prstGeom>
-          <a:solidFill>
-            <a:srgbClr val="EB6834"/>
-          </a:solidFill>
-          <a:ln>
-            <a:noFill/>
-          </a:ln>
-          <a:effectLst/>
-        </p:spPr>
-        <p:style>
-          <a:lnRef idx="1">
-            <a:schemeClr val="accent1"/>
-          </a:lnRef>
-          <a:fillRef idx="3">
-            <a:schemeClr val="accent1"/>
-          </a:fillRef>
-          <a:effectRef idx="2">
-            <a:schemeClr val="accent1"/>
-          </a:effectRef>
-          <a:fontRef idx="minor">
-            <a:schemeClr val="lt1"/>
-          </a:fontRef>
-        </p:style>
-        <p:txBody>
-          <a:bodyPr rtlCol="0" anchor="ctr"/>
-          <a:lstStyle/>
-          <a:p>
-            <a:pPr algn="ctr"/>
-          </a:p>
-        </p:txBody>
-      </p:sp>
-      <p:sp>
-        <p:nvSpPr>
-          <p:cNvPr id="21" name="TextBox 20"/>
-          <p:cNvSpPr txBox="1"/>
-          <p:nvPr/>
-        </p:nvSpPr>
-        <p:spPr>
-          <a:xfrm>
-            <a:off x="6446520" y="3977640"/>
-            <a:ext cx="5029200" cy="457200"/>
-          </a:xfrm>
-          <a:prstGeom prst="rect">
-            <a:avLst/>
-          </a:prstGeom>
-          <a:noFill/>
-        </p:spPr>
-        <p:txBody>
-          <a:bodyPr wrap="square" anchor="t" lIns="45720" rIns="45720" tIns="27432" bIns="27432">
-            <a:spAutoFit/>
-          </a:bodyPr>
-          <a:lstStyle/>
-          <a:p>
-            <a:pPr algn="l">
-              <a:spcAft>
-                <a:spcPts val="600"/>
-              </a:spcAft>
-            </a:pPr>
-            <a:r>
-              <a:rPr sz="1900" b="1">
-                <a:solidFill>
-                  <a:srgbClr val="0B0B0B"/>
-                </a:solidFill>
-                <a:latin typeface="Calibri"/>
-              </a:rPr>
-              <a:t>AlphaFold3 fills the gaps</a:t>
-            </a:r>
-          </a:p>
-        </p:txBody>
-      </p:sp>
-      <p:sp>
-        <p:nvSpPr>
-          <p:cNvPr id="22" name="TextBox 21"/>
-          <p:cNvSpPr txBox="1"/>
-          <p:nvPr/>
-        </p:nvSpPr>
-        <p:spPr>
-          <a:xfrm>
-            <a:off x="6446520" y="4526280"/>
-            <a:ext cx="5029200" cy="1280160"/>
-          </a:xfrm>
-          <a:prstGeom prst="rect">
-            <a:avLst/>
-          </a:prstGeom>
-          <a:noFill/>
-        </p:spPr>
-        <p:txBody>
-          <a:bodyPr wrap="square" anchor="t" lIns="45720" rIns="45720" tIns="27432" bIns="27432">
-            <a:spAutoFit/>
-          </a:bodyPr>
-          <a:lstStyle/>
-          <a:p>
-            <a:pPr algn="l">
-              <a:spcAft>
-                <a:spcPts val="600"/>
-              </a:spcAft>
-            </a:pPr>
-            <a:r>
-              <a:rPr sz="1400" b="0">
-                <a:solidFill>
-                  <a:srgbClr val="52514E"/>
-                </a:solidFill>
-                <a:latin typeface="Calibri"/>
-              </a:rPr>
-              <a:t>TM 0.92–0.97 on all three, including the T1127 insertion and the T1151s2 tail. Remaining errors are at disordered termini.</a:t>
+              <a:t>Result: accurate even where MODELLER had nothing (T1127 insertion 0.9 Å, T1151s2 tail 1.5 Å).</a:t>
             </a:r>
           </a:p>
         </p:txBody>
@@ -8772,7 +8954,7 @@
                 </a:solidFill>
                 <a:latin typeface="Calibri"/>
               </a:rPr>
-              <a:t>Limitations</a:t>
+              <a:t>Key findings</a:t>
             </a:r>
           </a:p>
         </p:txBody>
@@ -8892,14 +9074,102 @@
       </p:sp>
       <p:sp>
         <p:nvSpPr>
-          <p:cNvPr id="7" name="TextBox 6"/>
+          <p:cNvPr id="7" name="Rectangle 6"/>
+          <p:cNvSpPr/>
+          <p:nvPr/>
+        </p:nvSpPr>
+        <p:spPr>
+          <a:xfrm>
+            <a:off x="548640" y="1463040"/>
+            <a:ext cx="5440680" cy="2103120"/>
+          </a:xfrm>
+          <a:prstGeom prst="rect">
+            <a:avLst/>
+          </a:prstGeom>
+          <a:solidFill>
+            <a:srgbClr val="F5F4F1"/>
+          </a:solidFill>
+          <a:ln>
+            <a:noFill/>
+          </a:ln>
+          <a:effectLst/>
+        </p:spPr>
+        <p:style>
+          <a:lnRef idx="1">
+            <a:schemeClr val="accent1"/>
+          </a:lnRef>
+          <a:fillRef idx="3">
+            <a:schemeClr val="accent1"/>
+          </a:fillRef>
+          <a:effectRef idx="2">
+            <a:schemeClr val="accent1"/>
+          </a:effectRef>
+          <a:fontRef idx="minor">
+            <a:schemeClr val="lt1"/>
+          </a:fontRef>
+        </p:style>
+        <p:txBody>
+          <a:bodyPr rtlCol="0" anchor="ctr"/>
+          <a:lstStyle/>
+          <a:p>
+            <a:pPr algn="ctr"/>
+          </a:p>
+        </p:txBody>
+      </p:sp>
+      <p:sp>
+        <p:nvSpPr>
+          <p:cNvPr id="8" name="Rectangle 7"/>
+          <p:cNvSpPr/>
+          <p:nvPr/>
+        </p:nvSpPr>
+        <p:spPr>
+          <a:xfrm>
+            <a:off x="548640" y="1463040"/>
+            <a:ext cx="82296" cy="2103120"/>
+          </a:xfrm>
+          <a:prstGeom prst="rect">
+            <a:avLst/>
+          </a:prstGeom>
+          <a:solidFill>
+            <a:srgbClr val="2A78D6"/>
+          </a:solidFill>
+          <a:ln>
+            <a:noFill/>
+          </a:ln>
+          <a:effectLst/>
+        </p:spPr>
+        <p:style>
+          <a:lnRef idx="1">
+            <a:schemeClr val="accent1"/>
+          </a:lnRef>
+          <a:fillRef idx="3">
+            <a:schemeClr val="accent1"/>
+          </a:fillRef>
+          <a:effectRef idx="2">
+            <a:schemeClr val="accent1"/>
+          </a:effectRef>
+          <a:fontRef idx="minor">
+            <a:schemeClr val="lt1"/>
+          </a:fontRef>
+        </p:style>
+        <p:txBody>
+          <a:bodyPr rtlCol="0" anchor="ctr"/>
+          <a:lstStyle/>
+          <a:p>
+            <a:pPr algn="ctr"/>
+          </a:p>
+        </p:txBody>
+      </p:sp>
+      <p:sp>
+        <p:nvSpPr>
+          <p:cNvPr id="9" name="TextBox 8"/>
           <p:cNvSpPr txBox="1"/>
           <p:nvPr/>
         </p:nvSpPr>
         <p:spPr>
           <a:xfrm>
-            <a:off x="548640" y="1463040"/>
-            <a:ext cx="11064240" cy="4572000"/>
+            <a:off x="822959" y="1645920"/>
+            <a:ext cx="5029200" cy="457200"/>
           </a:xfrm>
           <a:prstGeom prst="rect">
             <a:avLst/>
@@ -8914,81 +9184,554 @@
           <a:p>
             <a:pPr algn="l">
               <a:spcAft>
-                <a:spcPts val="1200"/>
+                <a:spcPts val="600"/>
               </a:spcAft>
             </a:pPr>
             <a:r>
-              <a:rPr sz="1600" b="0">
+              <a:rPr sz="1900" b="1">
                 <a:solidFill>
                   <a:srgbClr val="0B0B0B"/>
                 </a:solidFill>
                 <a:latin typeface="Calibri"/>
               </a:rPr>
-              <a:t>•  Three targets, one MODELLER and one AlphaFold3 model each: case studies, not trends.</a:t>
-            </a:r>
-          </a:p>
+              <a:t>Template coverage sets the ceiling</a:t>
+            </a:r>
+          </a:p>
+        </p:txBody>
+      </p:sp>
+      <p:sp>
+        <p:nvSpPr>
+          <p:cNvPr id="10" name="TextBox 9"/>
+          <p:cNvSpPr txBox="1"/>
+          <p:nvPr/>
+        </p:nvSpPr>
+        <p:spPr>
+          <a:xfrm>
+            <a:off x="822959" y="2194560"/>
+            <a:ext cx="5029200" cy="1280160"/>
+          </a:xfrm>
+          <a:prstGeom prst="rect">
+            <a:avLst/>
+          </a:prstGeom>
+          <a:noFill/>
+        </p:spPr>
+        <p:txBody>
+          <a:bodyPr wrap="square" anchor="t" lIns="45720" rIns="45720" tIns="27432" bIns="27432">
+            <a:spAutoFit/>
+          </a:bodyPr>
+          <a:lstStyle/>
           <a:p>
             <a:pPr algn="l">
               <a:spcAft>
-                <a:spcPts val="1200"/>
+                <a:spcPts val="600"/>
               </a:spcAft>
             </a:pPr>
             <a:r>
-              <a:rPr sz="1600" b="0">
-                <a:solidFill>
-                  <a:srgbClr val="0B0B0B"/>
-                </a:solidFill>
-                <a:latin typeface="Calibri"/>
-              </a:rPr>
-              <a:t>•  Only single-template models; combining templates or modelling the T1124 dimer might fix part of the uncovered or misplaced regions.</a:t>
-            </a:r>
-          </a:p>
+              <a:rPr sz="1400" b="0">
+                <a:solidFill>
+                  <a:srgbClr val="52514E"/>
+                </a:solidFill>
+                <a:latin typeface="Calibri"/>
+              </a:rPr>
+              <a:t>Covered residues: 1.9 Å (T1127), 1.7 Å (T1151s2) mean Cα error. Uncovered: 22–35 Å. Residues without a template are essentially guessed.</a:t>
+            </a:r>
+          </a:p>
+        </p:txBody>
+      </p:sp>
+      <p:sp>
+        <p:nvSpPr>
+          <p:cNvPr id="11" name="Rectangle 10"/>
+          <p:cNvSpPr/>
+          <p:nvPr/>
+        </p:nvSpPr>
+        <p:spPr>
+          <a:xfrm>
+            <a:off x="6172200" y="1463040"/>
+            <a:ext cx="5440680" cy="2103120"/>
+          </a:xfrm>
+          <a:prstGeom prst="rect">
+            <a:avLst/>
+          </a:prstGeom>
+          <a:solidFill>
+            <a:srgbClr val="F5F4F1"/>
+          </a:solidFill>
+          <a:ln>
+            <a:noFill/>
+          </a:ln>
+          <a:effectLst/>
+        </p:spPr>
+        <p:style>
+          <a:lnRef idx="1">
+            <a:schemeClr val="accent1"/>
+          </a:lnRef>
+          <a:fillRef idx="3">
+            <a:schemeClr val="accent1"/>
+          </a:fillRef>
+          <a:effectRef idx="2">
+            <a:schemeClr val="accent1"/>
+          </a:effectRef>
+          <a:fontRef idx="minor">
+            <a:schemeClr val="lt1"/>
+          </a:fontRef>
+        </p:style>
+        <p:txBody>
+          <a:bodyPr rtlCol="0" anchor="ctr"/>
+          <a:lstStyle/>
+          <a:p>
+            <a:pPr algn="ctr"/>
+          </a:p>
+        </p:txBody>
+      </p:sp>
+      <p:sp>
+        <p:nvSpPr>
+          <p:cNvPr id="12" name="Rectangle 11"/>
+          <p:cNvSpPr/>
+          <p:nvPr/>
+        </p:nvSpPr>
+        <p:spPr>
+          <a:xfrm>
+            <a:off x="6172200" y="1463040"/>
+            <a:ext cx="82296" cy="2103120"/>
+          </a:xfrm>
+          <a:prstGeom prst="rect">
+            <a:avLst/>
+          </a:prstGeom>
+          <a:solidFill>
+            <a:srgbClr val="2A78D6"/>
+          </a:solidFill>
+          <a:ln>
+            <a:noFill/>
+          </a:ln>
+          <a:effectLst/>
+        </p:spPr>
+        <p:style>
+          <a:lnRef idx="1">
+            <a:schemeClr val="accent1"/>
+          </a:lnRef>
+          <a:fillRef idx="3">
+            <a:schemeClr val="accent1"/>
+          </a:fillRef>
+          <a:effectRef idx="2">
+            <a:schemeClr val="accent1"/>
+          </a:effectRef>
+          <a:fontRef idx="minor">
+            <a:schemeClr val="lt1"/>
+          </a:fontRef>
+        </p:style>
+        <p:txBody>
+          <a:bodyPr rtlCol="0" anchor="ctr"/>
+          <a:lstStyle/>
+          <a:p>
+            <a:pPr algn="ctr"/>
+          </a:p>
+        </p:txBody>
+      </p:sp>
+      <p:sp>
+        <p:nvSpPr>
+          <p:cNvPr id="13" name="TextBox 12"/>
+          <p:cNvSpPr txBox="1"/>
+          <p:nvPr/>
+        </p:nvSpPr>
+        <p:spPr>
+          <a:xfrm>
+            <a:off x="6446520" y="1645920"/>
+            <a:ext cx="5029200" cy="457200"/>
+          </a:xfrm>
+          <a:prstGeom prst="rect">
+            <a:avLst/>
+          </a:prstGeom>
+          <a:noFill/>
+        </p:spPr>
+        <p:txBody>
+          <a:bodyPr wrap="square" anchor="t" lIns="45720" rIns="45720" tIns="27432" bIns="27432">
+            <a:spAutoFit/>
+          </a:bodyPr>
+          <a:lstStyle/>
           <a:p>
             <a:pPr algn="l">
               <a:spcAft>
-                <a:spcPts val="1200"/>
+                <a:spcPts val="600"/>
               </a:spcAft>
             </a:pPr>
             <a:r>
-              <a:rPr sz="1600" b="0">
+              <a:rPr sz="1900" b="1">
                 <a:solidFill>
                   <a:srgbClr val="0B0B0B"/>
                 </a:solidFill>
                 <a:latin typeface="Calibri"/>
               </a:rPr>
-              <a:t>•  Alternative builds Claude rejected were not scored against the experimental structure, so we cannot say whether they would have been better.</a:t>
-            </a:r>
-          </a:p>
+              <a:t>Coverage is not enough</a:t>
+            </a:r>
+          </a:p>
+        </p:txBody>
+      </p:sp>
+      <p:sp>
+        <p:nvSpPr>
+          <p:cNvPr id="14" name="TextBox 13"/>
+          <p:cNvSpPr txBox="1"/>
+          <p:nvPr/>
+        </p:nvSpPr>
+        <p:spPr>
+          <a:xfrm>
+            <a:off x="6446520" y="2194560"/>
+            <a:ext cx="5029200" cy="1280160"/>
+          </a:xfrm>
+          <a:prstGeom prst="rect">
+            <a:avLst/>
+          </a:prstGeom>
+          <a:noFill/>
+        </p:spPr>
+        <p:txBody>
+          <a:bodyPr wrap="square" anchor="t" lIns="45720" rIns="45720" tIns="27432" bIns="27432">
+            <a:spAutoFit/>
+          </a:bodyPr>
+          <a:lstStyle/>
           <a:p>
             <a:pPr algn="l">
               <a:spcAft>
-                <a:spcPts val="1200"/>
+                <a:spcPts val="600"/>
               </a:spcAft>
             </a:pPr>
             <a:r>
-              <a:rPr sz="1600" b="0">
-                <a:solidFill>
-                  <a:srgbClr val="0B0B0B"/>
-                </a:solidFill>
-                <a:latin typeface="Calibri"/>
-              </a:rPr>
-              <a:t>•  Evaluation is limited to the CASP evaluation units; T1127 has 7 unobserved EU residues, and T1151s2 is one chain of a complex (scored as a monomer).</a:t>
-            </a:r>
-          </a:p>
+              <a:rPr sz="1400" b="0">
+                <a:solidFill>
+                  <a:srgbClr val="52514E"/>
+                </a:solidFill>
+                <a:latin typeface="Calibri"/>
+              </a:rPr>
+              <a:t>T1124: 81% aligned, but a whole domain is misplaced. At ~27% identity a single template can carry the wrong domain arrangement.</a:t>
+            </a:r>
+          </a:p>
+        </p:txBody>
+      </p:sp>
+      <p:sp>
+        <p:nvSpPr>
+          <p:cNvPr id="15" name="Rectangle 14"/>
+          <p:cNvSpPr/>
+          <p:nvPr/>
+        </p:nvSpPr>
+        <p:spPr>
+          <a:xfrm>
+            <a:off x="548640" y="3794760"/>
+            <a:ext cx="5440680" cy="2103120"/>
+          </a:xfrm>
+          <a:prstGeom prst="rect">
+            <a:avLst/>
+          </a:prstGeom>
+          <a:solidFill>
+            <a:srgbClr val="F5F4F1"/>
+          </a:solidFill>
+          <a:ln>
+            <a:noFill/>
+          </a:ln>
+          <a:effectLst/>
+        </p:spPr>
+        <p:style>
+          <a:lnRef idx="1">
+            <a:schemeClr val="accent1"/>
+          </a:lnRef>
+          <a:fillRef idx="3">
+            <a:schemeClr val="accent1"/>
+          </a:fillRef>
+          <a:effectRef idx="2">
+            <a:schemeClr val="accent1"/>
+          </a:effectRef>
+          <a:fontRef idx="minor">
+            <a:schemeClr val="lt1"/>
+          </a:fontRef>
+        </p:style>
+        <p:txBody>
+          <a:bodyPr rtlCol="0" anchor="ctr"/>
+          <a:lstStyle/>
+          <a:p>
+            <a:pPr algn="ctr"/>
+          </a:p>
+        </p:txBody>
+      </p:sp>
+      <p:sp>
+        <p:nvSpPr>
+          <p:cNvPr id="16" name="Rectangle 15"/>
+          <p:cNvSpPr/>
+          <p:nvPr/>
+        </p:nvSpPr>
+        <p:spPr>
+          <a:xfrm>
+            <a:off x="548640" y="3794760"/>
+            <a:ext cx="82296" cy="2103120"/>
+          </a:xfrm>
+          <a:prstGeom prst="rect">
+            <a:avLst/>
+          </a:prstGeom>
+          <a:solidFill>
+            <a:srgbClr val="EB6834"/>
+          </a:solidFill>
+          <a:ln>
+            <a:noFill/>
+          </a:ln>
+          <a:effectLst/>
+        </p:spPr>
+        <p:style>
+          <a:lnRef idx="1">
+            <a:schemeClr val="accent1"/>
+          </a:lnRef>
+          <a:fillRef idx="3">
+            <a:schemeClr val="accent1"/>
+          </a:fillRef>
+          <a:effectRef idx="2">
+            <a:schemeClr val="accent1"/>
+          </a:effectRef>
+          <a:fontRef idx="minor">
+            <a:schemeClr val="lt1"/>
+          </a:fontRef>
+        </p:style>
+        <p:txBody>
+          <a:bodyPr rtlCol="0" anchor="ctr"/>
+          <a:lstStyle/>
+          <a:p>
+            <a:pPr algn="ctr"/>
+          </a:p>
+        </p:txBody>
+      </p:sp>
+      <p:sp>
+        <p:nvSpPr>
+          <p:cNvPr id="17" name="TextBox 16"/>
+          <p:cNvSpPr txBox="1"/>
+          <p:nvPr/>
+        </p:nvSpPr>
+        <p:spPr>
+          <a:xfrm>
+            <a:off x="822959" y="3977640"/>
+            <a:ext cx="5029200" cy="457200"/>
+          </a:xfrm>
+          <a:prstGeom prst="rect">
+            <a:avLst/>
+          </a:prstGeom>
+          <a:noFill/>
+        </p:spPr>
+        <p:txBody>
+          <a:bodyPr wrap="square" anchor="t" lIns="45720" rIns="45720" tIns="27432" bIns="27432">
+            <a:spAutoFit/>
+          </a:bodyPr>
+          <a:lstStyle/>
           <a:p>
             <a:pPr algn="l">
               <a:spcAft>
-                <a:spcPts val="1200"/>
+                <a:spcPts val="600"/>
               </a:spcAft>
             </a:pPr>
             <a:r>
-              <a:rPr sz="1600" b="0">
+              <a:rPr sz="1900" b="1">
                 <a:solidFill>
                   <a:srgbClr val="0B0B0B"/>
                 </a:solidFill>
                 <a:latin typeface="Calibri"/>
               </a:rPr>
-              <a:t>•  AlphaFold Server also uses PDB templates (for T1151s2 the same WhiB family) plus large sequence alignments: the comparison is method vs method, not template vs no template.</a:t>
+              <a:t>Profile search finds remote templates</a:t>
+            </a:r>
+          </a:p>
+        </p:txBody>
+      </p:sp>
+      <p:sp>
+        <p:nvSpPr>
+          <p:cNvPr id="18" name="TextBox 17"/>
+          <p:cNvSpPr txBox="1"/>
+          <p:nvPr/>
+        </p:nvSpPr>
+        <p:spPr>
+          <a:xfrm>
+            <a:off x="822959" y="4526280"/>
+            <a:ext cx="5029200" cy="1280160"/>
+          </a:xfrm>
+          <a:prstGeom prst="rect">
+            <a:avLst/>
+          </a:prstGeom>
+          <a:noFill/>
+        </p:spPr>
+        <p:txBody>
+          <a:bodyPr wrap="square" anchor="t" lIns="45720" rIns="45720" tIns="27432" bIns="27432">
+            <a:spAutoFit/>
+          </a:bodyPr>
+          <a:lstStyle/>
+          <a:p>
+            <a:pPr algn="l">
+              <a:spcAft>
+                <a:spcPts val="600"/>
+              </a:spcAft>
+            </a:pPr>
+            <a:r>
+              <a:rPr sz="1400" b="0">
+                <a:solidFill>
+                  <a:srgbClr val="52514E"/>
+                </a:solidFill>
+                <a:latin typeface="Calibri"/>
+              </a:rPr>
+              <a:t>T1151s2 (FM/TBM): WhiB-family templates at 38% identity over 55 residues (E ≈ 1e-22) give an accurate core, TM 0.52.</a:t>
+            </a:r>
+          </a:p>
+        </p:txBody>
+      </p:sp>
+      <p:sp>
+        <p:nvSpPr>
+          <p:cNvPr id="19" name="Rectangle 18"/>
+          <p:cNvSpPr/>
+          <p:nvPr/>
+        </p:nvSpPr>
+        <p:spPr>
+          <a:xfrm>
+            <a:off x="6172200" y="3794760"/>
+            <a:ext cx="5440680" cy="2103120"/>
+          </a:xfrm>
+          <a:prstGeom prst="rect">
+            <a:avLst/>
+          </a:prstGeom>
+          <a:solidFill>
+            <a:srgbClr val="F5F4F1"/>
+          </a:solidFill>
+          <a:ln>
+            <a:noFill/>
+          </a:ln>
+          <a:effectLst/>
+        </p:spPr>
+        <p:style>
+          <a:lnRef idx="1">
+            <a:schemeClr val="accent1"/>
+          </a:lnRef>
+          <a:fillRef idx="3">
+            <a:schemeClr val="accent1"/>
+          </a:fillRef>
+          <a:effectRef idx="2">
+            <a:schemeClr val="accent1"/>
+          </a:effectRef>
+          <a:fontRef idx="minor">
+            <a:schemeClr val="lt1"/>
+          </a:fontRef>
+        </p:style>
+        <p:txBody>
+          <a:bodyPr rtlCol="0" anchor="ctr"/>
+          <a:lstStyle/>
+          <a:p>
+            <a:pPr algn="ctr"/>
+          </a:p>
+        </p:txBody>
+      </p:sp>
+      <p:sp>
+        <p:nvSpPr>
+          <p:cNvPr id="20" name="Rectangle 19"/>
+          <p:cNvSpPr/>
+          <p:nvPr/>
+        </p:nvSpPr>
+        <p:spPr>
+          <a:xfrm>
+            <a:off x="6172200" y="3794760"/>
+            <a:ext cx="82296" cy="2103120"/>
+          </a:xfrm>
+          <a:prstGeom prst="rect">
+            <a:avLst/>
+          </a:prstGeom>
+          <a:solidFill>
+            <a:srgbClr val="EB6834"/>
+          </a:solidFill>
+          <a:ln>
+            <a:noFill/>
+          </a:ln>
+          <a:effectLst/>
+        </p:spPr>
+        <p:style>
+          <a:lnRef idx="1">
+            <a:schemeClr val="accent1"/>
+          </a:lnRef>
+          <a:fillRef idx="3">
+            <a:schemeClr val="accent1"/>
+          </a:fillRef>
+          <a:effectRef idx="2">
+            <a:schemeClr val="accent1"/>
+          </a:effectRef>
+          <a:fontRef idx="minor">
+            <a:schemeClr val="lt1"/>
+          </a:fontRef>
+        </p:style>
+        <p:txBody>
+          <a:bodyPr rtlCol="0" anchor="ctr"/>
+          <a:lstStyle/>
+          <a:p>
+            <a:pPr algn="ctr"/>
+          </a:p>
+        </p:txBody>
+      </p:sp>
+      <p:sp>
+        <p:nvSpPr>
+          <p:cNvPr id="21" name="TextBox 20"/>
+          <p:cNvSpPr txBox="1"/>
+          <p:nvPr/>
+        </p:nvSpPr>
+        <p:spPr>
+          <a:xfrm>
+            <a:off x="6446520" y="3977640"/>
+            <a:ext cx="5029200" cy="457200"/>
+          </a:xfrm>
+          <a:prstGeom prst="rect">
+            <a:avLst/>
+          </a:prstGeom>
+          <a:noFill/>
+        </p:spPr>
+        <p:txBody>
+          <a:bodyPr wrap="square" anchor="t" lIns="45720" rIns="45720" tIns="27432" bIns="27432">
+            <a:spAutoFit/>
+          </a:bodyPr>
+          <a:lstStyle/>
+          <a:p>
+            <a:pPr algn="l">
+              <a:spcAft>
+                <a:spcPts val="600"/>
+              </a:spcAft>
+            </a:pPr>
+            <a:r>
+              <a:rPr sz="1900" b="1">
+                <a:solidFill>
+                  <a:srgbClr val="0B0B0B"/>
+                </a:solidFill>
+                <a:latin typeface="Calibri"/>
+              </a:rPr>
+              <a:t>AlphaFold3 fills the gaps</a:t>
+            </a:r>
+          </a:p>
+        </p:txBody>
+      </p:sp>
+      <p:sp>
+        <p:nvSpPr>
+          <p:cNvPr id="22" name="TextBox 21"/>
+          <p:cNvSpPr txBox="1"/>
+          <p:nvPr/>
+        </p:nvSpPr>
+        <p:spPr>
+          <a:xfrm>
+            <a:off x="6446520" y="4526280"/>
+            <a:ext cx="5029200" cy="1280160"/>
+          </a:xfrm>
+          <a:prstGeom prst="rect">
+            <a:avLst/>
+          </a:prstGeom>
+          <a:noFill/>
+        </p:spPr>
+        <p:txBody>
+          <a:bodyPr wrap="square" anchor="t" lIns="45720" rIns="45720" tIns="27432" bIns="27432">
+            <a:spAutoFit/>
+          </a:bodyPr>
+          <a:lstStyle/>
+          <a:p>
+            <a:pPr algn="l">
+              <a:spcAft>
+                <a:spcPts val="600"/>
+              </a:spcAft>
+            </a:pPr>
+            <a:r>
+              <a:rPr sz="1400" b="0">
+                <a:solidFill>
+                  <a:srgbClr val="52514E"/>
+                </a:solidFill>
+                <a:latin typeface="Calibri"/>
+              </a:rPr>
+              <a:t>TM 0.92–0.97 on all three, including the T1127 insertion and the T1151s2 tail. Remaining errors are at disordered termini.</a:t>
             </a:r>
           </a:p>
         </p:txBody>
@@ -9045,7 +9788,7 @@
                 </a:solidFill>
                 <a:latin typeface="Calibri"/>
               </a:rPr>
-              <a:t>SUMMARY</a:t>
+              <a:t>DISCUSSION</a:t>
             </a:r>
           </a:p>
         </p:txBody>
@@ -9084,7 +9827,7 @@
                 </a:solidFill>
                 <a:latin typeface="Calibri"/>
               </a:rPr>
-              <a:t>Conclusion</a:t>
+              <a:t>Limitations</a:t>
             </a:r>
           </a:p>
         </p:txBody>
@@ -9159,6 +9902,318 @@
                 <a:latin typeface="Calibri"/>
               </a:rPr>
               <a:t>15</a:t>
+            </a:r>
+          </a:p>
+        </p:txBody>
+      </p:sp>
+      <p:sp>
+        <p:nvSpPr>
+          <p:cNvPr id="6" name="TextBox 5"/>
+          <p:cNvSpPr txBox="1"/>
+          <p:nvPr/>
+        </p:nvSpPr>
+        <p:spPr>
+          <a:xfrm>
+            <a:off x="548640" y="6473952"/>
+            <a:ext cx="7315200" cy="274320"/>
+          </a:xfrm>
+          <a:prstGeom prst="rect">
+            <a:avLst/>
+          </a:prstGeom>
+          <a:noFill/>
+        </p:spPr>
+        <p:txBody>
+          <a:bodyPr wrap="square" anchor="t" lIns="45720" rIns="45720" tIns="27432" bIns="27432">
+            <a:spAutoFit/>
+          </a:bodyPr>
+          <a:lstStyle/>
+          <a:p>
+            <a:pPr algn="l">
+              <a:spcAft>
+                <a:spcPts val="600"/>
+              </a:spcAft>
+            </a:pPr>
+            <a:r>
+              <a:rPr sz="1000" b="0">
+                <a:solidFill>
+                  <a:srgbClr val="52514E"/>
+                </a:solidFill>
+                <a:latin typeface="Calibri"/>
+              </a:rPr>
+              <a:t>CMP_SC 8170 · Project 2 · Template-based modeling vs AlphaFold3</a:t>
+            </a:r>
+          </a:p>
+        </p:txBody>
+      </p:sp>
+      <p:sp>
+        <p:nvSpPr>
+          <p:cNvPr id="7" name="TextBox 6"/>
+          <p:cNvSpPr txBox="1"/>
+          <p:nvPr/>
+        </p:nvSpPr>
+        <p:spPr>
+          <a:xfrm>
+            <a:off x="548640" y="1463040"/>
+            <a:ext cx="11064240" cy="4572000"/>
+          </a:xfrm>
+          <a:prstGeom prst="rect">
+            <a:avLst/>
+          </a:prstGeom>
+          <a:noFill/>
+        </p:spPr>
+        <p:txBody>
+          <a:bodyPr wrap="square" anchor="t" lIns="45720" rIns="45720" tIns="27432" bIns="27432">
+            <a:spAutoFit/>
+          </a:bodyPr>
+          <a:lstStyle/>
+          <a:p>
+            <a:pPr algn="l">
+              <a:spcAft>
+                <a:spcPts val="1200"/>
+              </a:spcAft>
+            </a:pPr>
+            <a:r>
+              <a:rPr sz="1600" b="0">
+                <a:solidFill>
+                  <a:srgbClr val="0B0B0B"/>
+                </a:solidFill>
+                <a:latin typeface="Calibri"/>
+              </a:rPr>
+              <a:t>•  Three targets, one MODELLER and one AlphaFold3 model each: case studies, not trends.</a:t>
+            </a:r>
+          </a:p>
+          <a:p>
+            <a:pPr algn="l">
+              <a:spcAft>
+                <a:spcPts val="1200"/>
+              </a:spcAft>
+            </a:pPr>
+            <a:r>
+              <a:rPr sz="1600" b="0">
+                <a:solidFill>
+                  <a:srgbClr val="0B0B0B"/>
+                </a:solidFill>
+                <a:latin typeface="Calibri"/>
+              </a:rPr>
+              <a:t>•  Only single-template models; combining templates or modelling the T1124 dimer might fix part of the uncovered or misplaced regions.</a:t>
+            </a:r>
+          </a:p>
+          <a:p>
+            <a:pPr algn="l">
+              <a:spcAft>
+                <a:spcPts val="1200"/>
+              </a:spcAft>
+            </a:pPr>
+            <a:r>
+              <a:rPr sz="1600" b="0">
+                <a:solidFill>
+                  <a:srgbClr val="0B0B0B"/>
+                </a:solidFill>
+                <a:latin typeface="Calibri"/>
+              </a:rPr>
+              <a:t>•  Alternative builds Claude rejected were not scored against the experimental structure, so we cannot say whether they would have been better.</a:t>
+            </a:r>
+          </a:p>
+          <a:p>
+            <a:pPr algn="l">
+              <a:spcAft>
+                <a:spcPts val="1200"/>
+              </a:spcAft>
+            </a:pPr>
+            <a:r>
+              <a:rPr sz="1600" b="0">
+                <a:solidFill>
+                  <a:srgbClr val="0B0B0B"/>
+                </a:solidFill>
+                <a:latin typeface="Calibri"/>
+              </a:rPr>
+              <a:t>•  Evaluation is limited to the CASP evaluation units; T1127 has 7 unobserved EU residues, and T1151s2 is one chain of a complex (scored as a monomer).</a:t>
+            </a:r>
+          </a:p>
+          <a:p>
+            <a:pPr algn="l">
+              <a:spcAft>
+                <a:spcPts val="1200"/>
+              </a:spcAft>
+            </a:pPr>
+            <a:r>
+              <a:rPr sz="1600" b="0">
+                <a:solidFill>
+                  <a:srgbClr val="0B0B0B"/>
+                </a:solidFill>
+                <a:latin typeface="Calibri"/>
+              </a:rPr>
+              <a:t>•  AlphaFold Server also uses PDB templates (for T1151s2 the same WhiB family) plus large sequence alignments: the comparison is method vs method, not template vs no template.</a:t>
+            </a:r>
+          </a:p>
+        </p:txBody>
+      </p:sp>
+    </p:spTree>
+  </p:cSld>
+  <p:clrMapOvr>
+    <a:masterClrMapping/>
+  </p:clrMapOvr>
+</p:sld>
+</file>
+
+<file path=ppt/slides/slide16.xml><?xml version="1.0" encoding="utf-8"?>
+<p:sld xmlns:a="http://schemas.openxmlformats.org/drawingml/2006/main" xmlns:p="http://schemas.openxmlformats.org/presentationml/2006/main" xmlns:r="http://schemas.openxmlformats.org/officeDocument/2006/relationships">
+  <p:cSld>
+    <p:spTree>
+      <p:nvGrpSpPr>
+        <p:cNvPr id="1" name=""/>
+        <p:cNvGrpSpPr/>
+        <p:nvPr/>
+      </p:nvGrpSpPr>
+      <p:grpSpPr/>
+      <p:sp>
+        <p:nvSpPr>
+          <p:cNvPr id="2" name="TextBox 1"/>
+          <p:cNvSpPr txBox="1"/>
+          <p:nvPr/>
+        </p:nvSpPr>
+        <p:spPr>
+          <a:xfrm>
+            <a:off x="548640" y="292608"/>
+            <a:ext cx="10972800" cy="274320"/>
+          </a:xfrm>
+          <a:prstGeom prst="rect">
+            <a:avLst/>
+          </a:prstGeom>
+          <a:noFill/>
+        </p:spPr>
+        <p:txBody>
+          <a:bodyPr wrap="square" anchor="t" lIns="45720" rIns="45720" tIns="27432" bIns="27432">
+            <a:spAutoFit/>
+          </a:bodyPr>
+          <a:lstStyle/>
+          <a:p>
+            <a:pPr algn="l">
+              <a:spcAft>
+                <a:spcPts val="600"/>
+              </a:spcAft>
+            </a:pPr>
+            <a:r>
+              <a:rPr sz="1100" b="1">
+                <a:solidFill>
+                  <a:srgbClr val="2A78D6"/>
+                </a:solidFill>
+                <a:latin typeface="Calibri"/>
+              </a:rPr>
+              <a:t>SUMMARY</a:t>
+            </a:r>
+          </a:p>
+        </p:txBody>
+      </p:sp>
+      <p:sp>
+        <p:nvSpPr>
+          <p:cNvPr id="3" name="TextBox 2"/>
+          <p:cNvSpPr txBox="1"/>
+          <p:nvPr/>
+        </p:nvSpPr>
+        <p:spPr>
+          <a:xfrm>
+            <a:off x="548640" y="502920"/>
+            <a:ext cx="11064240" cy="640080"/>
+          </a:xfrm>
+          <a:prstGeom prst="rect">
+            <a:avLst/>
+          </a:prstGeom>
+          <a:noFill/>
+        </p:spPr>
+        <p:txBody>
+          <a:bodyPr wrap="square" anchor="t" lIns="45720" rIns="45720" tIns="27432" bIns="27432">
+            <a:spAutoFit/>
+          </a:bodyPr>
+          <a:lstStyle/>
+          <a:p>
+            <a:pPr algn="l">
+              <a:spcAft>
+                <a:spcPts val="600"/>
+              </a:spcAft>
+            </a:pPr>
+            <a:r>
+              <a:rPr sz="2800" b="1">
+                <a:solidFill>
+                  <a:srgbClr val="0B0B0B"/>
+                </a:solidFill>
+                <a:latin typeface="Calibri"/>
+              </a:rPr>
+              <a:t>Conclusion</a:t>
+            </a:r>
+          </a:p>
+        </p:txBody>
+      </p:sp>
+      <p:cxnSp>
+        <p:nvCxnSpPr>
+          <p:cNvPr id="4" name="Connector 3"/>
+          <p:cNvCxnSpPr/>
+          <p:nvPr/>
+        </p:nvCxnSpPr>
+        <p:spPr>
+          <a:xfrm>
+            <a:off x="548640" y="1170432"/>
+            <a:ext cx="11094415" cy="0"/>
+          </a:xfrm>
+          <a:prstGeom prst="line">
+            <a:avLst/>
+          </a:prstGeom>
+          <a:ln w="12700">
+            <a:solidFill>
+              <a:srgbClr val="E4E3DF"/>
+            </a:solidFill>
+          </a:ln>
+        </p:spPr>
+        <p:style>
+          <a:lnRef idx="2">
+            <a:schemeClr val="accent1"/>
+          </a:lnRef>
+          <a:fillRef idx="0">
+            <a:schemeClr val="accent1"/>
+          </a:fillRef>
+          <a:effectRef idx="1">
+            <a:schemeClr val="accent1"/>
+          </a:effectRef>
+          <a:fontRef idx="minor">
+            <a:schemeClr val="tx1"/>
+          </a:fontRef>
+        </p:style>
+      </p:cxnSp>
+      <p:sp>
+        <p:nvSpPr>
+          <p:cNvPr id="5" name="TextBox 4"/>
+          <p:cNvSpPr txBox="1"/>
+          <p:nvPr/>
+        </p:nvSpPr>
+        <p:spPr>
+          <a:xfrm>
+            <a:off x="11185855" y="6473952"/>
+            <a:ext cx="548640" cy="274320"/>
+          </a:xfrm>
+          <a:prstGeom prst="rect">
+            <a:avLst/>
+          </a:prstGeom>
+          <a:noFill/>
+        </p:spPr>
+        <p:txBody>
+          <a:bodyPr wrap="square" anchor="t" lIns="45720" rIns="45720" tIns="27432" bIns="27432">
+            <a:spAutoFit/>
+          </a:bodyPr>
+          <a:lstStyle/>
+          <a:p>
+            <a:pPr algn="r">
+              <a:spcAft>
+                <a:spcPts val="600"/>
+              </a:spcAft>
+            </a:pPr>
+            <a:r>
+              <a:rPr sz="1000" b="0">
+                <a:solidFill>
+                  <a:srgbClr val="52514E"/>
+                </a:solidFill>
+                <a:latin typeface="Calibri"/>
+              </a:rPr>
+              <a:t>16</a:t>
             </a:r>
           </a:p>
         </p:txBody>

</xml_diff>